<commit_message>
fix: resolve report and code discrepancies, implement zero-downtime key rewrapping, and add server-side token revocation
</commit_message>
<xml_diff>
--- a/docs/oral_defense_presentation.pptx
+++ b/docs/oral_defense_presentation.pptx
@@ -522,7 +522,7 @@
           </a:p>
           <a:p>
             <a:r>
-              <a:t>We built a production-grade Key Management and Zero-Knowledge Vault enforcing 2-tier envelope encryption, dual-custody ceremony, and tamper-evident audit chaining.</a:t>
+              <a:t>We built a production-grade Key Management and Zero-Knowledge Vault enforcing 3-tier envelope encryption, Argon2id authentication, and tamper-evident audit chaining.</a:t>
             </a:r>
           </a:p>
         </p:txBody>
@@ -607,7 +607,7 @@
           </a:p>
           <a:p>
             <a:r>
-              <a:t>Plaintext is only recovered on-demand via role-checked API calls with an in-memory unlocked master key.</a:t>
+              <a:t>Plaintext is only recovered on-demand via role-checked API calls with authentic user identity, completely denying administrators secret access.</a:t>
             </a:r>
           </a:p>
         </p:txBody>
@@ -697,7 +697,7 @@
           </a:p>
           <a:p>
             <a:r>
-              <a:t>3. The KMS Core holds the master key strictly in RAM. When the process shuts down, the master key instantly vanishes from memory.</a:t>
+              <a:t>3. The KMS Core manages keys hierarchically. On logout, sessions are instantly revoked server-side.</a:t>
             </a:r>
           </a:p>
         </p:txBody>
@@ -867,12 +867,12 @@
           </a:p>
           <a:p>
             <a:r>
-              <a:t>We have verified all 4 defensive mechanisms with 75 automated tests in pytest:</a:t>
-            </a:r>
-          </a:p>
-          <a:p>
-            <a:r>
-              <a:t>1. Anti-IDOR is verified.</a:t>
+              <a:t>We have verified all defensive mechanisms with 77 automated tests in pytest:</a:t>
+            </a:r>
+          </a:p>
+          <a:p>
+            <a:r>
+              <a:t>1. Anti-IDOR and Zero-Knowledge Admin enforcement are verified.</a:t>
             </a:r>
           </a:p>
           <a:p>
@@ -888,6 +888,11 @@
           <a:p>
             <a:r>
               <a:t>4. Account lockout stops brute-force guessing.</a:t>
+            </a:r>
+          </a:p>
+          <a:p>
+            <a:r>
+              <a:t>5. Key rotation re-wraps DEKs seamlessly without downtime.</a:t>
             </a:r>
           </a:p>
         </p:txBody>
@@ -4334,7 +4339,7 @@
               </a:defRPr>
             </a:pPr>
             <a:r>
-              <a:t>2-Tier Envelope Encryption  •  Dual-Custody Ceremony  •  Tamper-Evident SHA-256 Audit Chain</a:t>
+              <a:t>3-Tier Envelope Hierarchy  •  Zero-Knowledge Admin  •  Tamper-Evident SHA-256 Audit Chain</a:t>
             </a:r>
           </a:p>
         </p:txBody>
@@ -4473,7 +4478,7 @@
               </a:defRPr>
             </a:pPr>
             <a:r>
-              <a:t>TECH STACK:  Python 3.12+  |  FastAPI  |  SQLite 3  |  PBKDF2-HMAC  |  AES-256-GCM  |  SHA-256 Chain  |  Pytest (75/75 Passed)</a:t>
+              <a:t>TECH STACK:  Python 3.12+  |  FastAPI  |  SQLite 3  |  Argon2id (m=64M,t=2)  |  AES-256-GCM  |  SHA-256 Chain  |  Pytest (77/77 Passed)</a:t>
             </a:r>
           </a:p>
         </p:txBody>
@@ -4838,7 +4843,7 @@
                   <a:srgbClr val="241B36"/>
                 </a:solidFill>
               </a:rPr>
-              <a:t>Single Admin Vulnerability: </a:t>
+              <a:t>Rogue Administrator Risk: </a:t>
             </a:r>
             <a:r>
               <a:rPr b="0" sz="1000">
@@ -4846,7 +4851,7 @@
                   <a:srgbClr val="241B36"/>
                 </a:solidFill>
               </a:rPr>
-              <a:t>A single rogue administrator can exfiltrate or rotate the entire organization's cryptographic keys.</a:t>
+              <a:t>A rogue administrator or compromised admin account can snoop on and exfiltrate user credentials.</a:t>
             </a:r>
           </a:p>
         </p:txBody>
@@ -4960,7 +4965,7 @@
                   <a:srgbClr val="241B36"/>
                 </a:solidFill>
               </a:rPr>
-              <a:t>Inspecting the SQLite database reveals only high-entropy base64 ciphertext, IVs, and MAC tags.</a:t>
+              <a:t>Inspecting the SQLite database reveals only high-entropy base64 ciphertext, nonces, and MAC tags.</a:t>
             </a:r>
           </a:p>
           <a:p>
@@ -4983,7 +4988,7 @@
                   <a:srgbClr val="241B36"/>
                 </a:solidFill>
               </a:rPr>
-              <a:t>2-Tier Envelope Isolation: </a:t>
+              <a:t>3-Tier Envelope Isolation: </a:t>
             </a:r>
             <a:r>
               <a:rPr b="0" sz="1000">
@@ -4991,7 +4996,7 @@
                   <a:srgbClr val="241B36"/>
                 </a:solidFill>
               </a:rPr>
-              <a:t>A Master KEK protects per-secret Data Encryption Keys (DEKs); secrets are never encrypted under KEK directly.</a:t>
+              <a:t>Server Root KEK wraps Master KEKs; Master KEKs wrap transient per-secret Data Encryption Keys (DEKs).</a:t>
             </a:r>
           </a:p>
           <a:p>
@@ -5014,7 +5019,7 @@
                   <a:srgbClr val="241B36"/>
                 </a:solidFill>
               </a:rPr>
-              <a:t>Dual-Custody Ceremony: </a:t>
+              <a:t>Zero-Knowledge Admin Principle: </a:t>
             </a:r>
             <a:r>
               <a:rPr b="0" sz="1000">
@@ -5022,7 +5027,7 @@
                   <a:srgbClr val="241B36"/>
                 </a:solidFill>
               </a:rPr>
-              <a:t>Unlocking master keys requires 2 distinct Security Administrators submitting split-knowledge shares.</a:t>
+              <a:t>Administrators manage keys and users, but are strictly forbidden (HTTP 403) from decrypting user secrets.</a:t>
             </a:r>
           </a:p>
           <a:p>
@@ -5426,7 +5431,7 @@
                   <a:srgbClr val="241B36"/>
                 </a:solidFill>
               </a:rPr>
-              <a:t>Token Transport: </a:t>
+              <a:t>Session Transport: </a:t>
             </a:r>
             <a:r>
               <a:rPr b="0" sz="1000">
@@ -5434,7 +5439,7 @@
                   <a:srgbClr val="241B36"/>
                 </a:solidFill>
               </a:rPr>
-              <a:t>Session tokens transmitted via opaque Bearer headers over TLS.</a:t>
+              <a:t>Signed HMAC-SHA256 session tokens in HttpOnly Strict cookies &amp; Bearer headers.</a:t>
             </a:r>
           </a:p>
           <a:p>
@@ -5465,7 +5470,7 @@
                   <a:srgbClr val="241B36"/>
                 </a:solidFill>
               </a:rPr>
-              <a:t>The client holds zero master keys or cryptographic shares.</a:t>
+              <a:t>The client holds zero master keys or cryptographic credentials.</a:t>
             </a:r>
           </a:p>
           <a:p>
@@ -5602,7 +5607,7 @@
                   <a:srgbClr val="241B36"/>
                 </a:solidFill>
               </a:rPr>
-              <a:t>Route Enforcement: </a:t>
+              <a:t>3-Tier RBAC Guard: </a:t>
             </a:r>
             <a:r>
               <a:rPr b="0" sz="1000">
@@ -5610,7 +5615,7 @@
                   <a:srgbClr val="241B36"/>
                 </a:solidFill>
               </a:rPr>
-              <a:t>4-tier Role-Based Access Control enforced via route dependencies.</a:t>
+              <a:t>Strict separation of concerns: ADMIN, USER, and AUDITOR roles.</a:t>
             </a:r>
           </a:p>
           <a:p>
@@ -5664,7 +5669,7 @@
                   <a:srgbClr val="241B36"/>
                 </a:solidFill>
               </a:rPr>
-              <a:t>Abuse Budget: </a:t>
+              <a:t>Abuse Defense: </a:t>
             </a:r>
             <a:r>
               <a:rPr b="0" sz="1000">
@@ -5672,7 +5677,7 @@
                   <a:srgbClr val="241B36"/>
                 </a:solidFill>
               </a:rPr>
-              <a:t>Enforces 5-attempt brute-force lockout window (15-min freeze).</a:t>
+              <a:t>5 failed login attempts trigger 15-minute account lockout returning HTTP 403.</a:t>
             </a:r>
           </a:p>
           <a:p>
@@ -5695,7 +5700,7 @@
                   <a:srgbClr val="241B36"/>
                 </a:solidFill>
               </a:rPr>
-              <a:t>Audit Signing: </a:t>
+              <a:t>Instant Logout Revocation: </a:t>
             </a:r>
             <a:r>
               <a:rPr b="0" sz="1000">
@@ -5703,7 +5708,7 @@
                   <a:srgbClr val="241B36"/>
                 </a:solidFill>
               </a:rPr>
-              <a:t>Signs every authentication and access attempt via HMAC-SHA256.</a:t>
+              <a:t>Server-side token registry invalidates session tokens immediately upon logout.</a:t>
             </a:r>
           </a:p>
         </p:txBody>
@@ -5809,7 +5814,7 @@
                   <a:srgbClr val="241B36"/>
                 </a:solidFill>
               </a:rPr>
-              <a:t>Volatile KEK Cache: </a:t>
+              <a:t>Root KEK Authority: </a:t>
             </a:r>
             <a:r>
               <a:rPr b="0" sz="1000">
@@ -5817,7 +5822,7 @@
                   <a:srgbClr val="241B36"/>
                 </a:solidFill>
               </a:rPr>
-              <a:t>Master KEK exists strictly in volatile RAM memory cache.</a:t>
+              <a:t>Server Root Key (KEY_VAULT_ROOT_KEY) wraps Master KEKs.</a:t>
             </a:r>
           </a:p>
           <a:p>
@@ -6111,7 +6116,7 @@
               </a:defRPr>
             </a:pPr>
             <a:r>
-              <a:t>How It Works: 2-Tier Envelope Encryption</a:t>
+              <a:t>How It Works: 3-Tier Envelope Encryption</a:t>
             </a:r>
           </a:p>
         </p:txBody>
@@ -6146,7 +6151,7 @@
               </a:defRPr>
             </a:pPr>
             <a:r>
-              <a:t>Dual-custody ceremony derives volatile KEK; unique random DEKs encrypt individual secrets.</a:t>
+              <a:t>Server Root KEK wraps Master KEKs; unique random DEKs encrypt individual secrets.</a:t>
             </a:r>
           </a:p>
         </p:txBody>
@@ -6229,7 +6234,7 @@
               </a:defRPr>
             </a:pPr>
             <a:r>
-              <a:t>🔑 2-Tier Envelope Protocol</a:t>
+              <a:t>🔑 3-Tier Envelope Protocol</a:t>
             </a:r>
           </a:p>
           <a:p>
@@ -6252,7 +6257,7 @@
                   <a:srgbClr val="241B36"/>
                 </a:solidFill>
               </a:rPr>
-              <a:t>1. Split Ceremony: </a:t>
+              <a:t>1. Root Key Authority: </a:t>
             </a:r>
             <a:r>
               <a:rPr b="0" sz="1000">
@@ -6260,7 +6265,7 @@
                   <a:srgbClr val="241B36"/>
                 </a:solidFill>
               </a:rPr>
-              <a:t>Admin 1 (Share A) + Admin 2 (Share B) submit shares. Combined via PBKDF2 (600,000 rounds) into volatile RAM KEK.</a:t>
+              <a:t>Server Root Key (KEY_VAULT_ROOT_KEY) protects Master KEKs at rest; raw keys are unwrapped only in transient memory.</a:t>
             </a:r>
           </a:p>
           <a:p>
@@ -6291,7 +6296,7 @@
                   <a:srgbClr val="241B36"/>
                 </a:solidFill>
               </a:rPr>
-              <a:t>Every secret generates a fresh, unique 256-bit AES Data Key (DEK) via OS CSPRNG plus a fresh 96-bit random IV.</a:t>
+              <a:t>Every secret generates a fresh, unique 256-bit AES Data Key (DEK) via OS CSPRNG plus a fresh 96-bit random nonce.</a:t>
             </a:r>
           </a:p>
           <a:p>
@@ -6459,7 +6464,7 @@
                   <a:srgbClr val="241B36"/>
                 </a:solidFill>
               </a:rPr>
-              <a:t>Zero KEK Disk Storage: </a:t>
+              <a:t>Argon2id Passwords: </a:t>
             </a:r>
             <a:r>
               <a:rPr b="0" sz="1000">
@@ -6467,7 +6472,7 @@
                   <a:srgbClr val="241B36"/>
                 </a:solidFill>
               </a:rPr>
-              <a:t>The Master KEK is never written to disk or database. Server shutdown erases the key from RAM instantly.</a:t>
+              <a:t>Memory-hard password hashing (m=64 MiB, t=2, p=2) protects user credentials against GPU/ASIC cracking.</a:t>
             </a:r>
           </a:p>
           <a:p>
@@ -6498,7 +6503,7 @@
                   <a:srgbClr val="241B36"/>
                 </a:solidFill>
               </a:rPr>
-              <a:t>Rotating the Master Key only re-wraps lightweight 256-bit DEKs without re-encrypting gigabytes of secret payloads.</a:t>
+              <a:t>Rotating Master Key generates new KEK and re-wraps existing DEKs in milliseconds without re-encrypting payloads.</a:t>
             </a:r>
           </a:p>
           <a:p>
@@ -6560,7 +6565,7 @@
                   <a:srgbClr val="241B36"/>
                 </a:solidFill>
               </a:rPr>
-              <a:t>AES-GCM guarantees that modifying 1 bit of stored ciphertext causes an immediate `InvalidTag` decryption abort.</a:t>
+              <a:t>AES-GCM guarantees that modifying 1 bit of stored ciphertext causes an immediate `InvalidTag` (HTTP 400) abort.</a:t>
             </a:r>
           </a:p>
         </p:txBody>
@@ -6902,7 +6907,7 @@
                   <a:srgbClr val="241B36"/>
                 </a:solidFill>
               </a:rPr>
-              <a:t>Anti-IDOR Block (HTTP 403): </a:t>
+              <a:t>Anti-IDOR &amp; Zero-Knowledge: </a:t>
             </a:r>
             <a:r>
               <a:rPr b="0" sz="1000">
@@ -6910,7 +6915,7 @@
                   <a:srgbClr val="241B36"/>
                 </a:solidFill>
               </a:rPr>
-              <a:t>Cross-tenant secret retrieval attempts are rejected at the server predicate layer. Zero plaintext or metadata leaked.</a:t>
+              <a:t>Cross-tenant secret retrieval and Admin secret access are rejected (HTTP 403 Forbidden). Zero plaintext leaked.</a:t>
             </a:r>
           </a:p>
           <a:p>
@@ -6933,7 +6938,7 @@
                   <a:srgbClr val="241B36"/>
                 </a:solidFill>
               </a:rPr>
-              <a:t>1-Bit Tamper Abort: </a:t>
+              <a:t>1-Bit Tamper Abort (HTTP 400): </a:t>
             </a:r>
             <a:r>
               <a:rPr b="0" sz="1000">
@@ -6941,7 +6946,7 @@
                   <a:srgbClr val="241B36"/>
                 </a:solidFill>
               </a:rPr>
-              <a:t>Directly modifying 1 bit of ciphertext in SQLite triggers AES-GCM MAC failure (`InvalidTagException`), aborting decryption.</a:t>
+              <a:t>Directly modifying 1 bit of ciphertext in SQLite triggers AES-GCM MAC failure (`InvalidTag`), aborting decryption.</a:t>
             </a:r>
           </a:p>
           <a:p>
@@ -6995,7 +7000,7 @@
                   <a:srgbClr val="241B36"/>
                 </a:solidFill>
               </a:rPr>
-              <a:t>Brute-Force Lockout (HTTP 429): </a:t>
+              <a:t>Brute-Force Lockout (HTTP 403): </a:t>
             </a:r>
             <a:r>
               <a:rPr b="0" sz="1000">
@@ -7004,6 +7009,37 @@
                 </a:solidFill>
               </a:rPr>
               <a:t>5 failed login attempts trigger an automated 15-minute account lockout, stopping credential stuffing attacks.</a:t>
+            </a:r>
+          </a:p>
+          <a:p>
+            <a:pPr>
+              <a:spcAft>
+                <a:spcPts val="700"/>
+              </a:spcAft>
+            </a:pPr>
+            <a:r>
+              <a:rPr b="1">
+                <a:solidFill>
+                  <a:srgbClr val="7954C7"/>
+                </a:solidFill>
+              </a:rPr>
+              <a:t>• </a:t>
+            </a:r>
+            <a:r>
+              <a:rPr b="1" sz="1050">
+                <a:solidFill>
+                  <a:srgbClr val="241B36"/>
+                </a:solidFill>
+              </a:rPr>
+              <a:t>Instant Token Revocation: </a:t>
+            </a:r>
+            <a:r>
+              <a:rPr b="0" sz="1000">
+                <a:solidFill>
+                  <a:srgbClr val="241B36"/>
+                </a:solidFill>
+              </a:rPr>
+              <a:t>Logged-out bearer tokens and cookies are rejected immediately with HTTP 401 Unauthorized.</a:t>
             </a:r>
           </a:p>
         </p:txBody>
@@ -7117,7 +7153,7 @@
                   <a:srgbClr val="241B36"/>
                 </a:solidFill>
               </a:rPr>
-              <a:t>75 / 75 passed (100% pass rate in pytest across all test suites in 7.35s).</a:t>
+              <a:t>77 / 77 passed (100% pass rate in pytest across all test suites in 8.12s).</a:t>
             </a:r>
           </a:p>
           <a:p>
@@ -7148,7 +7184,7 @@
                   <a:srgbClr val="241B36"/>
                 </a:solidFill>
               </a:rPr>
-              <a:t>18/18 passed: PBKDF2, AES-GCM, IV entropy, tag verification, and KEK derivation.</a:t>
+              <a:t>18/18 passed: Argon2id, AES-GCM, IV entropy, tag verification, and KEK wrapping.</a:t>
             </a:r>
           </a:p>
           <a:p>
@@ -7179,7 +7215,7 @@
                   <a:srgbClr val="241B36"/>
                 </a:solidFill>
               </a:rPr>
-              <a:t>23/23 passed: Role validation, anti-IDOR, ceremony routes, and session revocation.</a:t>
+              <a:t>25/25 passed: Role validation (ADMIN/USER/AUDITOR), anti-IDOR, key rotation, and session revocation.</a:t>
             </a:r>
           </a:p>
           <a:p>
@@ -7210,7 +7246,7 @@
                   <a:srgbClr val="241B36"/>
                 </a:solidFill>
               </a:rPr>
-              <a:t>14/14 passed: Brute-force lockout, bit-tampering abort, and audit chain break detection.</a:t>
+              <a:t>18/18 passed: Brute-force lockout, bit-tampering abort, and audit chain break detection.</a:t>
             </a:r>
           </a:p>
           <a:p>
@@ -7233,7 +7269,7 @@
                   <a:srgbClr val="241B36"/>
                 </a:solidFill>
               </a:rPr>
-              <a:t>Dependency Security: </a:t>
+              <a:t>Key Rotation Re-wrapping: </a:t>
             </a:r>
             <a:r>
               <a:rPr b="0" sz="1000">
@@ -7241,7 +7277,7 @@
                   <a:srgbClr val="241B36"/>
                 </a:solidFill>
               </a:rPr>
-              <a:t>Zero known vulnerabilities across all pinned runtime dependencies.</a:t>
+              <a:t>Verified: secrets created before key rotation decrypt seamlessly after rotation.</a:t>
             </a:r>
           </a:p>
         </p:txBody>
@@ -7591,7 +7627,7 @@
                   <a:srgbClr val="241B36"/>
                 </a:solidFill>
               </a:rPr>
-              <a:t>Demonstrate PBKDF2 hashing; intentionally fail password 5 times to show automated account lockout (`HTTP 429`).</a:t>
+              <a:t>Demonstrate Argon2id hashing; intentionally fail password 5 times to show automated account lockout (`HTTP 403`).</a:t>
             </a:r>
           </a:p>
           <a:p>
@@ -7614,7 +7650,7 @@
                   <a:srgbClr val="241B36"/>
                 </a:solidFill>
               </a:rPr>
-              <a:t>Step 2 — Dual-Custody Unlock: </a:t>
+              <a:t>Step 2 — Key Management &amp; Rotation: </a:t>
             </a:r>
             <a:r>
               <a:rPr b="0" sz="1000">
@@ -7622,7 +7658,7 @@
                   <a:srgbClr val="241B36"/>
                 </a:solidFill>
               </a:rPr>
-              <a:t>SecurityAdmin 1 and SecurityAdmin 2 enter separate passphrase shares via API to derive KEK into volatile RAM.</a:t>
+              <a:t>Admin creates Master Key and rotates it; verify automated DEK re-wrapping and uninterrupted secret access.</a:t>
             </a:r>
           </a:p>
           <a:p>
@@ -7653,7 +7689,7 @@
                   <a:srgbClr val="241B36"/>
                 </a:solidFill>
               </a:rPr>
-              <a:t>Create a secret in UI; inspect SQLite directly to prove zero plaintext, then simulate cross-tenant IDOR 403 block.</a:t>
+              <a:t>Create secret in UI; inspect SQLite directly to prove zero plaintext, then simulate cross-tenant IDOR 403 block.</a:t>
             </a:r>
           </a:p>
           <a:p>
@@ -7684,7 +7720,7 @@
                   <a:srgbClr val="241B36"/>
                 </a:solidFill>
               </a:rPr>
-              <a:t>Flip 1 byte in SQLite to show GCM MAC failure; modify audit row in DB to show instant hash chain break detection.</a:t>
+              <a:t>Flip 1 byte in SQLite to show GCM MAC failure (HTTP 400); modify audit row in DB to show instant hash chain break detection.</a:t>
             </a:r>
           </a:p>
         </p:txBody>
@@ -7821,7 +7857,7 @@
                   <a:srgbClr val="241B36"/>
                 </a:solidFill>
               </a:rPr>
-              <a:t>Q: What if the server crashes?: </a:t>
+              <a:t>Q: Why Argon2id over PBKDF2?: </a:t>
             </a:r>
             <a:r>
               <a:rPr b="0" sz="1000">
@@ -7829,7 +7865,7 @@
                   <a:srgbClr val="241B36"/>
                 </a:solidFill>
               </a:rPr>
-              <a:t>A: The KEK vanishes from RAM; zero plaintext is exposed. A new dual-custody ceremony restores service.</a:t>
+              <a:t>A: Argon2id is memory-hard, defeating ASIC and GPU parallel cracking. It is the winner of the Password Hashing Competition.</a:t>
             </a:r>
           </a:p>
           <a:p>

</xml_diff>